<commit_message>
Add proposal PPTX: Lucero PC (August 18, 2026)
Updated urgency score (6→7) and traffic lights to match the re-triggered
research pass's refreshed section 05 assessment.
</commit_message>
<xml_diff>
--- a/lucero/Lucero PC_August 18, 2026_Proposal.pptx
+++ b/lucero/Lucero PC_August 18, 2026_Proposal.pptx
@@ -3319,7 +3319,7 @@
                 </a:solidFill>
                 <a:latin typeface="Poppins"/>
               </a:rPr>
-              <a:t>6</a:t>
+              <a:t>7</a:t>
             </a:r>
           </a:p>
         </p:txBody>
@@ -3366,6 +3366,384 @@
         <p:spPr>
           <a:xfrm>
             <a:off x="1682496" y="1005840"/>
+            <a:ext cx="804672" cy="164592"/>
+          </a:xfrm>
+          <a:prstGeom prst="rect">
+            <a:avLst/>
+          </a:prstGeom>
+          <a:solidFill>
+            <a:srgbClr val="C0392B"/>
+          </a:solidFill>
+          <a:ln>
+            <a:solidFill>
+              <a:srgbClr val="FFFFFF"/>
+            </a:solidFill>
+          </a:ln>
+        </p:spPr>
+        <p:style>
+          <a:lnRef idx="1">
+            <a:schemeClr val="accent1"/>
+          </a:lnRef>
+          <a:fillRef idx="3">
+            <a:schemeClr val="accent1"/>
+          </a:fillRef>
+          <a:effectRef idx="2">
+            <a:schemeClr val="accent1"/>
+          </a:effectRef>
+          <a:fontRef idx="minor">
+            <a:schemeClr val="lt1"/>
+          </a:fontRef>
+        </p:style>
+        <p:txBody>
+          <a:bodyPr rtlCol="0" anchor="ctr"/>
+          <a:lstStyle/>
+          <a:p>
+            <a:pPr algn="ctr"/>
+          </a:p>
+        </p:txBody>
+      </p:sp>
+      <p:sp>
+        <p:nvSpPr>
+          <p:cNvPr id="10" name="Rectangle 9"/>
+          <p:cNvSpPr/>
+          <p:nvPr/>
+        </p:nvSpPr>
+        <p:spPr>
+          <a:xfrm>
+            <a:off x="1682496" y="1170432"/>
+            <a:ext cx="804672" cy="676656"/>
+          </a:xfrm>
+          <a:prstGeom prst="rect">
+            <a:avLst/>
+          </a:prstGeom>
+          <a:solidFill>
+            <a:srgbClr val="265872"/>
+          </a:solidFill>
+          <a:ln>
+            <a:solidFill>
+              <a:srgbClr val="FFFFFF"/>
+            </a:solidFill>
+          </a:ln>
+        </p:spPr>
+        <p:style>
+          <a:lnRef idx="1">
+            <a:schemeClr val="accent1"/>
+          </a:lnRef>
+          <a:fillRef idx="3">
+            <a:schemeClr val="accent1"/>
+          </a:fillRef>
+          <a:effectRef idx="2">
+            <a:schemeClr val="accent1"/>
+          </a:effectRef>
+          <a:fontRef idx="minor">
+            <a:schemeClr val="lt1"/>
+          </a:fontRef>
+        </p:style>
+        <p:txBody>
+          <a:bodyPr rtlCol="0" anchor="ctr"/>
+          <a:lstStyle/>
+          <a:p>
+            <a:pPr algn="ctr"/>
+          </a:p>
+        </p:txBody>
+      </p:sp>
+      <p:sp>
+        <p:nvSpPr>
+          <p:cNvPr id="11" name="TextBox 10"/>
+          <p:cNvSpPr txBox="1"/>
+          <p:nvPr/>
+        </p:nvSpPr>
+        <p:spPr>
+          <a:xfrm>
+            <a:off x="1737360" y="1188720"/>
+            <a:ext cx="694944" cy="237744"/>
+          </a:xfrm>
+          <a:prstGeom prst="rect">
+            <a:avLst/>
+          </a:prstGeom>
+          <a:noFill/>
+        </p:spPr>
+        <p:txBody>
+          <a:bodyPr wrap="square"/>
+          <a:lstStyle/>
+          <a:p>
+            <a:pPr algn="l"/>
+            <a:r>
+              <a:rPr sz="800" b="1" i="0">
+                <a:solidFill>
+                  <a:srgbClr val="FFFFFF"/>
+                </a:solidFill>
+                <a:latin typeface="Poppins"/>
+              </a:rPr>
+              <a:t>Lead Generation</a:t>
+            </a:r>
+          </a:p>
+        </p:txBody>
+      </p:sp>
+      <p:sp>
+        <p:nvSpPr>
+          <p:cNvPr id="12" name="TextBox 11"/>
+          <p:cNvSpPr txBox="1"/>
+          <p:nvPr/>
+        </p:nvSpPr>
+        <p:spPr>
+          <a:xfrm>
+            <a:off x="1737360" y="1417320"/>
+            <a:ext cx="694944" cy="182880"/>
+          </a:xfrm>
+          <a:prstGeom prst="rect">
+            <a:avLst/>
+          </a:prstGeom>
+          <a:noFill/>
+        </p:spPr>
+        <p:txBody>
+          <a:bodyPr wrap="square"/>
+          <a:lstStyle/>
+          <a:p>
+            <a:pPr algn="l"/>
+            <a:r>
+              <a:rPr sz="700" b="1" i="0">
+                <a:solidFill>
+                  <a:srgbClr val="C0392B"/>
+                </a:solidFill>
+                <a:latin typeface="Poppins"/>
+              </a:rPr>
+              <a:t>RED</a:t>
+            </a:r>
+          </a:p>
+        </p:txBody>
+      </p:sp>
+      <p:sp>
+        <p:nvSpPr>
+          <p:cNvPr id="13" name="TextBox 12"/>
+          <p:cNvSpPr txBox="1"/>
+          <p:nvPr/>
+        </p:nvSpPr>
+        <p:spPr>
+          <a:xfrm>
+            <a:off x="1737360" y="1591056"/>
+            <a:ext cx="694944" cy="237744"/>
+          </a:xfrm>
+          <a:prstGeom prst="rect">
+            <a:avLst/>
+          </a:prstGeom>
+          <a:noFill/>
+        </p:spPr>
+        <p:txBody>
+          <a:bodyPr wrap="square"/>
+          <a:lstStyle/>
+          <a:p>
+            <a:pPr algn="l"/>
+            <a:r>
+              <a:rPr sz="700" b="0" i="0">
+                <a:solidFill>
+                  <a:srgbClr val="8BADD0"/>
+                </a:solidFill>
+                <a:latin typeface="Poppins"/>
+              </a:rPr>
+              <a:t>Unprofitable PPC spend</a:t>
+            </a:r>
+          </a:p>
+        </p:txBody>
+      </p:sp>
+      <p:sp>
+        <p:nvSpPr>
+          <p:cNvPr id="14" name="Rectangle 13"/>
+          <p:cNvSpPr/>
+          <p:nvPr/>
+        </p:nvSpPr>
+        <p:spPr>
+          <a:xfrm>
+            <a:off x="2542032" y="1005840"/>
+            <a:ext cx="804672" cy="164592"/>
+          </a:xfrm>
+          <a:prstGeom prst="rect">
+            <a:avLst/>
+          </a:prstGeom>
+          <a:solidFill>
+            <a:srgbClr val="C0392B"/>
+          </a:solidFill>
+          <a:ln>
+            <a:solidFill>
+              <a:srgbClr val="FFFFFF"/>
+            </a:solidFill>
+          </a:ln>
+        </p:spPr>
+        <p:style>
+          <a:lnRef idx="1">
+            <a:schemeClr val="accent1"/>
+          </a:lnRef>
+          <a:fillRef idx="3">
+            <a:schemeClr val="accent1"/>
+          </a:fillRef>
+          <a:effectRef idx="2">
+            <a:schemeClr val="accent1"/>
+          </a:effectRef>
+          <a:fontRef idx="minor">
+            <a:schemeClr val="lt1"/>
+          </a:fontRef>
+        </p:style>
+        <p:txBody>
+          <a:bodyPr rtlCol="0" anchor="ctr"/>
+          <a:lstStyle/>
+          <a:p>
+            <a:pPr algn="ctr"/>
+          </a:p>
+        </p:txBody>
+      </p:sp>
+      <p:sp>
+        <p:nvSpPr>
+          <p:cNvPr id="15" name="Rectangle 14"/>
+          <p:cNvSpPr/>
+          <p:nvPr/>
+        </p:nvSpPr>
+        <p:spPr>
+          <a:xfrm>
+            <a:off x="2542032" y="1170432"/>
+            <a:ext cx="804672" cy="676656"/>
+          </a:xfrm>
+          <a:prstGeom prst="rect">
+            <a:avLst/>
+          </a:prstGeom>
+          <a:solidFill>
+            <a:srgbClr val="265872"/>
+          </a:solidFill>
+          <a:ln>
+            <a:solidFill>
+              <a:srgbClr val="FFFFFF"/>
+            </a:solidFill>
+          </a:ln>
+        </p:spPr>
+        <p:style>
+          <a:lnRef idx="1">
+            <a:schemeClr val="accent1"/>
+          </a:lnRef>
+          <a:fillRef idx="3">
+            <a:schemeClr val="accent1"/>
+          </a:fillRef>
+          <a:effectRef idx="2">
+            <a:schemeClr val="accent1"/>
+          </a:effectRef>
+          <a:fontRef idx="minor">
+            <a:schemeClr val="lt1"/>
+          </a:fontRef>
+        </p:style>
+        <p:txBody>
+          <a:bodyPr rtlCol="0" anchor="ctr"/>
+          <a:lstStyle/>
+          <a:p>
+            <a:pPr algn="ctr"/>
+          </a:p>
+        </p:txBody>
+      </p:sp>
+      <p:sp>
+        <p:nvSpPr>
+          <p:cNvPr id="16" name="TextBox 15"/>
+          <p:cNvSpPr txBox="1"/>
+          <p:nvPr/>
+        </p:nvSpPr>
+        <p:spPr>
+          <a:xfrm>
+            <a:off x="2596896" y="1188720"/>
+            <a:ext cx="694944" cy="237744"/>
+          </a:xfrm>
+          <a:prstGeom prst="rect">
+            <a:avLst/>
+          </a:prstGeom>
+          <a:noFill/>
+        </p:spPr>
+        <p:txBody>
+          <a:bodyPr wrap="square"/>
+          <a:lstStyle/>
+          <a:p>
+            <a:pPr algn="l"/>
+            <a:r>
+              <a:rPr sz="800" b="1" i="0">
+                <a:solidFill>
+                  <a:srgbClr val="FFFFFF"/>
+                </a:solidFill>
+                <a:latin typeface="Poppins"/>
+              </a:rPr>
+              <a:t>Intake</a:t>
+            </a:r>
+          </a:p>
+        </p:txBody>
+      </p:sp>
+      <p:sp>
+        <p:nvSpPr>
+          <p:cNvPr id="17" name="TextBox 16"/>
+          <p:cNvSpPr txBox="1"/>
+          <p:nvPr/>
+        </p:nvSpPr>
+        <p:spPr>
+          <a:xfrm>
+            <a:off x="2596896" y="1417320"/>
+            <a:ext cx="694944" cy="182880"/>
+          </a:xfrm>
+          <a:prstGeom prst="rect">
+            <a:avLst/>
+          </a:prstGeom>
+          <a:noFill/>
+        </p:spPr>
+        <p:txBody>
+          <a:bodyPr wrap="square"/>
+          <a:lstStyle/>
+          <a:p>
+            <a:pPr algn="l"/>
+            <a:r>
+              <a:rPr sz="700" b="1" i="0">
+                <a:solidFill>
+                  <a:srgbClr val="C0392B"/>
+                </a:solidFill>
+                <a:latin typeface="Poppins"/>
+              </a:rPr>
+              <a:t>RED</a:t>
+            </a:r>
+          </a:p>
+        </p:txBody>
+      </p:sp>
+      <p:sp>
+        <p:nvSpPr>
+          <p:cNvPr id="18" name="TextBox 17"/>
+          <p:cNvSpPr txBox="1"/>
+          <p:nvPr/>
+        </p:nvSpPr>
+        <p:spPr>
+          <a:xfrm>
+            <a:off x="2596896" y="1591056"/>
+            <a:ext cx="694944" cy="237744"/>
+          </a:xfrm>
+          <a:prstGeom prst="rect">
+            <a:avLst/>
+          </a:prstGeom>
+          <a:noFill/>
+        </p:spPr>
+        <p:txBody>
+          <a:bodyPr wrap="square"/>
+          <a:lstStyle/>
+          <a:p>
+            <a:pPr algn="l"/>
+            <a:r>
+              <a:rPr sz="700" b="0" i="0">
+                <a:solidFill>
+                  <a:srgbClr val="8BADD0"/>
+                </a:solidFill>
+                <a:latin typeface="Poppins"/>
+              </a:rPr>
+              <a:t>Close rate now ~7%</a:t>
+            </a:r>
+          </a:p>
+        </p:txBody>
+      </p:sp>
+      <p:sp>
+        <p:nvSpPr>
+          <p:cNvPr id="19" name="Rectangle 18"/>
+          <p:cNvSpPr/>
+          <p:nvPr/>
+        </p:nvSpPr>
+        <p:spPr>
+          <a:xfrm>
+            <a:off x="3401568" y="1005840"/>
             <a:ext cx="804672" cy="164592"/>
           </a:xfrm>
           <a:prstGeom prst="rect">
@@ -3404,13 +3782,13 @@
       </p:sp>
       <p:sp>
         <p:nvSpPr>
-          <p:cNvPr id="10" name="Rectangle 9"/>
+          <p:cNvPr id="20" name="Rectangle 19"/>
           <p:cNvSpPr/>
           <p:nvPr/>
         </p:nvSpPr>
         <p:spPr>
           <a:xfrm>
-            <a:off x="1682496" y="1170432"/>
+            <a:off x="3401568" y="1170432"/>
             <a:ext cx="804672" cy="676656"/>
           </a:xfrm>
           <a:prstGeom prst="rect">
@@ -3449,13 +3827,13 @@
       </p:sp>
       <p:sp>
         <p:nvSpPr>
-          <p:cNvPr id="11" name="TextBox 10"/>
-          <p:cNvSpPr txBox="1"/>
-          <p:nvPr/>
-        </p:nvSpPr>
-        <p:spPr>
-          <a:xfrm>
-            <a:off x="1737360" y="1188720"/>
+          <p:cNvPr id="21" name="TextBox 20"/>
+          <p:cNvSpPr txBox="1"/>
+          <p:nvPr/>
+        </p:nvSpPr>
+        <p:spPr>
+          <a:xfrm>
+            <a:off x="3456432" y="1188720"/>
             <a:ext cx="694944" cy="237744"/>
           </a:xfrm>
           <a:prstGeom prst="rect">
@@ -3475,20 +3853,20 @@
                 </a:solidFill>
                 <a:latin typeface="Poppins"/>
               </a:rPr>
-              <a:t>Lead Generation</a:t>
-            </a:r>
-          </a:p>
-        </p:txBody>
-      </p:sp>
-      <p:sp>
-        <p:nvSpPr>
-          <p:cNvPr id="12" name="TextBox 11"/>
-          <p:cNvSpPr txBox="1"/>
-          <p:nvPr/>
-        </p:nvSpPr>
-        <p:spPr>
-          <a:xfrm>
-            <a:off x="1737360" y="1417320"/>
+              <a:t>Team</a:t>
+            </a:r>
+          </a:p>
+        </p:txBody>
+      </p:sp>
+      <p:sp>
+        <p:nvSpPr>
+          <p:cNvPr id="22" name="TextBox 21"/>
+          <p:cNvSpPr txBox="1"/>
+          <p:nvPr/>
+        </p:nvSpPr>
+        <p:spPr>
+          <a:xfrm>
+            <a:off x="3456432" y="1417320"/>
             <a:ext cx="694944" cy="182880"/>
           </a:xfrm>
           <a:prstGeom prst="rect">
@@ -3515,13 +3893,13 @@
       </p:sp>
       <p:sp>
         <p:nvSpPr>
-          <p:cNvPr id="13" name="TextBox 12"/>
-          <p:cNvSpPr txBox="1"/>
-          <p:nvPr/>
-        </p:nvSpPr>
-        <p:spPr>
-          <a:xfrm>
-            <a:off x="1737360" y="1591056"/>
+          <p:cNvPr id="23" name="TextBox 22"/>
+          <p:cNvSpPr txBox="1"/>
+          <p:nvPr/>
+        </p:nvSpPr>
+        <p:spPr>
+          <a:xfrm>
+            <a:off x="3456432" y="1591056"/>
             <a:ext cx="694944" cy="237744"/>
           </a:xfrm>
           <a:prstGeom prst="rect">
@@ -3541,20 +3919,20 @@
                 </a:solidFill>
                 <a:latin typeface="Poppins"/>
               </a:rPr>
-              <a:t>Unprofitable PPC spend</a:t>
-            </a:r>
-          </a:p>
-        </p:txBody>
-      </p:sp>
-      <p:sp>
-        <p:nvSpPr>
-          <p:cNvPr id="14" name="Rectangle 13"/>
+              <a:t>No associate yet</a:t>
+            </a:r>
+          </a:p>
+        </p:txBody>
+      </p:sp>
+      <p:sp>
+        <p:nvSpPr>
+          <p:cNvPr id="24" name="Rectangle 23"/>
           <p:cNvSpPr/>
           <p:nvPr/>
         </p:nvSpPr>
         <p:spPr>
           <a:xfrm>
-            <a:off x="2542032" y="1005840"/>
+            <a:off x="4261104" y="1005840"/>
             <a:ext cx="804672" cy="164592"/>
           </a:xfrm>
           <a:prstGeom prst="rect">
@@ -3593,13 +3971,13 @@
       </p:sp>
       <p:sp>
         <p:nvSpPr>
-          <p:cNvPr id="15" name="Rectangle 14"/>
+          <p:cNvPr id="25" name="Rectangle 24"/>
           <p:cNvSpPr/>
           <p:nvPr/>
         </p:nvSpPr>
         <p:spPr>
           <a:xfrm>
-            <a:off x="2542032" y="1170432"/>
+            <a:off x="4261104" y="1170432"/>
             <a:ext cx="804672" cy="676656"/>
           </a:xfrm>
           <a:prstGeom prst="rect">
@@ -3638,13 +4016,13 @@
       </p:sp>
       <p:sp>
         <p:nvSpPr>
-          <p:cNvPr id="16" name="TextBox 15"/>
-          <p:cNvSpPr txBox="1"/>
-          <p:nvPr/>
-        </p:nvSpPr>
-        <p:spPr>
-          <a:xfrm>
-            <a:off x="2596896" y="1188720"/>
+          <p:cNvPr id="26" name="TextBox 25"/>
+          <p:cNvSpPr txBox="1"/>
+          <p:nvPr/>
+        </p:nvSpPr>
+        <p:spPr>
+          <a:xfrm>
+            <a:off x="4315968" y="1188720"/>
             <a:ext cx="694944" cy="237744"/>
           </a:xfrm>
           <a:prstGeom prst="rect">
@@ -3664,20 +4042,20 @@
                 </a:solidFill>
                 <a:latin typeface="Poppins"/>
               </a:rPr>
-              <a:t>Intake</a:t>
-            </a:r>
-          </a:p>
-        </p:txBody>
-      </p:sp>
-      <p:sp>
-        <p:nvSpPr>
-          <p:cNvPr id="17" name="TextBox 16"/>
-          <p:cNvSpPr txBox="1"/>
-          <p:nvPr/>
-        </p:nvSpPr>
-        <p:spPr>
-          <a:xfrm>
-            <a:off x="2596896" y="1417320"/>
+              <a:t>Profit Plan</a:t>
+            </a:r>
+          </a:p>
+        </p:txBody>
+      </p:sp>
+      <p:sp>
+        <p:nvSpPr>
+          <p:cNvPr id="27" name="TextBox 26"/>
+          <p:cNvSpPr txBox="1"/>
+          <p:nvPr/>
+        </p:nvSpPr>
+        <p:spPr>
+          <a:xfrm>
+            <a:off x="4315968" y="1417320"/>
             <a:ext cx="694944" cy="182880"/>
           </a:xfrm>
           <a:prstGeom prst="rect">
@@ -3704,13 +4082,13 @@
       </p:sp>
       <p:sp>
         <p:nvSpPr>
-          <p:cNvPr id="18" name="TextBox 17"/>
-          <p:cNvSpPr txBox="1"/>
-          <p:nvPr/>
-        </p:nvSpPr>
-        <p:spPr>
-          <a:xfrm>
-            <a:off x="2596896" y="1591056"/>
+          <p:cNvPr id="28" name="TextBox 27"/>
+          <p:cNvSpPr txBox="1"/>
+          <p:nvPr/>
+        </p:nvSpPr>
+        <p:spPr>
+          <a:xfrm>
+            <a:off x="4315968" y="1591056"/>
             <a:ext cx="694944" cy="237744"/>
           </a:xfrm>
           <a:prstGeom prst="rect">
@@ -3730,21 +4108,99 @@
                 </a:solidFill>
                 <a:latin typeface="Poppins"/>
               </a:rPr>
-              <a:t>Close rate now ~7%</a:t>
-            </a:r>
-          </a:p>
-        </p:txBody>
-      </p:sp>
-      <p:sp>
-        <p:nvSpPr>
-          <p:cNvPr id="19" name="Rectangle 18"/>
+              <a:t>No profit visibility</a:t>
+            </a:r>
+          </a:p>
+        </p:txBody>
+      </p:sp>
+      <p:sp>
+        <p:nvSpPr>
+          <p:cNvPr id="29" name="TextBox 28"/>
+          <p:cNvSpPr txBox="1"/>
+          <p:nvPr/>
+        </p:nvSpPr>
+        <p:spPr>
+          <a:xfrm>
+            <a:off x="256032" y="1956816"/>
+            <a:ext cx="4846320" cy="219456"/>
+          </a:xfrm>
+          <a:prstGeom prst="rect">
+            <a:avLst/>
+          </a:prstGeom>
+          <a:noFill/>
+        </p:spPr>
+        <p:txBody>
+          <a:bodyPr wrap="square"/>
+          <a:lstStyle/>
+          <a:p>
+            <a:pPr algn="l"/>
+            <a:r>
+              <a:rPr sz="800" b="1" i="0">
+                <a:solidFill>
+                  <a:srgbClr val="69CD2B"/>
+                </a:solidFill>
+                <a:latin typeface="Poppins"/>
+              </a:rPr>
+              <a:t>KEY FINDINGS</a:t>
+            </a:r>
+          </a:p>
+        </p:txBody>
+      </p:sp>
+      <p:sp>
+        <p:nvSpPr>
+          <p:cNvPr id="30" name="Rectangle 29"/>
           <p:cNvSpPr/>
           <p:nvPr/>
         </p:nvSpPr>
         <p:spPr>
           <a:xfrm>
-            <a:off x="3401568" y="1005840"/>
-            <a:ext cx="804672" cy="164592"/>
+            <a:off x="256032" y="2212848"/>
+            <a:ext cx="4846320" cy="566928"/>
+          </a:xfrm>
+          <a:prstGeom prst="rect">
+            <a:avLst/>
+          </a:prstGeom>
+          <a:solidFill>
+            <a:srgbClr val="2C1010"/>
+          </a:solidFill>
+          <a:ln>
+            <a:solidFill>
+              <a:srgbClr val="FFFFFF"/>
+            </a:solidFill>
+          </a:ln>
+        </p:spPr>
+        <p:style>
+          <a:lnRef idx="1">
+            <a:schemeClr val="accent1"/>
+          </a:lnRef>
+          <a:fillRef idx="3">
+            <a:schemeClr val="accent1"/>
+          </a:fillRef>
+          <a:effectRef idx="2">
+            <a:schemeClr val="accent1"/>
+          </a:effectRef>
+          <a:fontRef idx="minor">
+            <a:schemeClr val="lt1"/>
+          </a:fontRef>
+        </p:style>
+        <p:txBody>
+          <a:bodyPr rtlCol="0" anchor="ctr"/>
+          <a:lstStyle/>
+          <a:p>
+            <a:pPr algn="ctr"/>
+          </a:p>
+        </p:txBody>
+      </p:sp>
+      <p:sp>
+        <p:nvSpPr>
+          <p:cNvPr id="31" name="Rectangle 30"/>
+          <p:cNvSpPr/>
+          <p:nvPr/>
+        </p:nvSpPr>
+        <p:spPr>
+          <a:xfrm>
+            <a:off x="365760" y="2386584"/>
+            <a:ext cx="219456" cy="219456"/>
           </a:xfrm>
           <a:prstGeom prst="rect">
             <a:avLst/>
@@ -3782,20 +4238,86 @@
       </p:sp>
       <p:sp>
         <p:nvSpPr>
-          <p:cNvPr id="20" name="Rectangle 19"/>
+          <p:cNvPr id="32" name="TextBox 31"/>
+          <p:cNvSpPr txBox="1"/>
+          <p:nvPr/>
+        </p:nvSpPr>
+        <p:spPr>
+          <a:xfrm>
+            <a:off x="365760" y="2368296"/>
+            <a:ext cx="219456" cy="237744"/>
+          </a:xfrm>
+          <a:prstGeom prst="rect">
+            <a:avLst/>
+          </a:prstGeom>
+          <a:noFill/>
+        </p:spPr>
+        <p:txBody>
+          <a:bodyPr wrap="square"/>
+          <a:lstStyle/>
+          <a:p>
+            <a:pPr algn="ctr"/>
+            <a:r>
+              <a:rPr sz="900" b="1" i="0">
+                <a:solidFill>
+                  <a:srgbClr val="FFFFFF"/>
+                </a:solidFill>
+                <a:latin typeface="Poppins"/>
+              </a:rPr>
+              <a:t>✕</a:t>
+            </a:r>
+          </a:p>
+        </p:txBody>
+      </p:sp>
+      <p:sp>
+        <p:nvSpPr>
+          <p:cNvPr id="33" name="TextBox 32"/>
+          <p:cNvSpPr txBox="1"/>
+          <p:nvPr/>
+        </p:nvSpPr>
+        <p:spPr>
+          <a:xfrm>
+            <a:off x="676656" y="2286000"/>
+            <a:ext cx="4352544" cy="420624"/>
+          </a:xfrm>
+          <a:prstGeom prst="rect">
+            <a:avLst/>
+          </a:prstGeom>
+          <a:noFill/>
+        </p:spPr>
+        <p:txBody>
+          <a:bodyPr wrap="square"/>
+          <a:lstStyle/>
+          <a:p>
+            <a:pPr algn="l"/>
+            <a:r>
+              <a:rPr sz="1000" b="0" i="0">
+                <a:solidFill>
+                  <a:srgbClr val="F0BABA"/>
+                </a:solidFill>
+                <a:latin typeface="Poppins"/>
+              </a:rPr>
+              <a:t>Unprofitable $5,800/mo PPC produces ~1 client a month</a:t>
+            </a:r>
+          </a:p>
+        </p:txBody>
+      </p:sp>
+      <p:sp>
+        <p:nvSpPr>
+          <p:cNvPr id="34" name="Rectangle 33"/>
           <p:cNvSpPr/>
           <p:nvPr/>
         </p:nvSpPr>
         <p:spPr>
           <a:xfrm>
-            <a:off x="3401568" y="1170432"/>
-            <a:ext cx="804672" cy="676656"/>
+            <a:off x="256032" y="2834640"/>
+            <a:ext cx="4846320" cy="566928"/>
           </a:xfrm>
           <a:prstGeom prst="rect">
             <a:avLst/>
           </a:prstGeom>
           <a:solidFill>
-            <a:srgbClr val="265872"/>
+            <a:srgbClr val="2C1010"/>
           </a:solidFill>
           <a:ln>
             <a:solidFill>
@@ -3827,113 +4349,14 @@
       </p:sp>
       <p:sp>
         <p:nvSpPr>
-          <p:cNvPr id="21" name="TextBox 20"/>
-          <p:cNvSpPr txBox="1"/>
-          <p:nvPr/>
-        </p:nvSpPr>
-        <p:spPr>
-          <a:xfrm>
-            <a:off x="3456432" y="1188720"/>
-            <a:ext cx="694944" cy="237744"/>
-          </a:xfrm>
-          <a:prstGeom prst="rect">
-            <a:avLst/>
-          </a:prstGeom>
-          <a:noFill/>
-        </p:spPr>
-        <p:txBody>
-          <a:bodyPr wrap="square"/>
-          <a:lstStyle/>
-          <a:p>
-            <a:pPr algn="l"/>
-            <a:r>
-              <a:rPr sz="800" b="1" i="0">
-                <a:solidFill>
-                  <a:srgbClr val="FFFFFF"/>
-                </a:solidFill>
-                <a:latin typeface="Poppins"/>
-              </a:rPr>
-              <a:t>Team</a:t>
-            </a:r>
-          </a:p>
-        </p:txBody>
-      </p:sp>
-      <p:sp>
-        <p:nvSpPr>
-          <p:cNvPr id="22" name="TextBox 21"/>
-          <p:cNvSpPr txBox="1"/>
-          <p:nvPr/>
-        </p:nvSpPr>
-        <p:spPr>
-          <a:xfrm>
-            <a:off x="3456432" y="1417320"/>
-            <a:ext cx="694944" cy="182880"/>
-          </a:xfrm>
-          <a:prstGeom prst="rect">
-            <a:avLst/>
-          </a:prstGeom>
-          <a:noFill/>
-        </p:spPr>
-        <p:txBody>
-          <a:bodyPr wrap="square"/>
-          <a:lstStyle/>
-          <a:p>
-            <a:pPr algn="l"/>
-            <a:r>
-              <a:rPr sz="700" b="1" i="0">
-                <a:solidFill>
-                  <a:srgbClr val="C0392B"/>
-                </a:solidFill>
-                <a:latin typeface="Poppins"/>
-              </a:rPr>
-              <a:t>RED</a:t>
-            </a:r>
-          </a:p>
-        </p:txBody>
-      </p:sp>
-      <p:sp>
-        <p:nvSpPr>
-          <p:cNvPr id="23" name="TextBox 22"/>
-          <p:cNvSpPr txBox="1"/>
-          <p:nvPr/>
-        </p:nvSpPr>
-        <p:spPr>
-          <a:xfrm>
-            <a:off x="3456432" y="1591056"/>
-            <a:ext cx="694944" cy="237744"/>
-          </a:xfrm>
-          <a:prstGeom prst="rect">
-            <a:avLst/>
-          </a:prstGeom>
-          <a:noFill/>
-        </p:spPr>
-        <p:txBody>
-          <a:bodyPr wrap="square"/>
-          <a:lstStyle/>
-          <a:p>
-            <a:pPr algn="l"/>
-            <a:r>
-              <a:rPr sz="700" b="0" i="0">
-                <a:solidFill>
-                  <a:srgbClr val="8BADD0"/>
-                </a:solidFill>
-                <a:latin typeface="Poppins"/>
-              </a:rPr>
-              <a:t>No associate yet</a:t>
-            </a:r>
-          </a:p>
-        </p:txBody>
-      </p:sp>
-      <p:sp>
-        <p:nvSpPr>
-          <p:cNvPr id="24" name="Rectangle 23"/>
+          <p:cNvPr id="35" name="Rectangle 34"/>
           <p:cNvSpPr/>
           <p:nvPr/>
         </p:nvSpPr>
         <p:spPr>
           <a:xfrm>
-            <a:off x="4261104" y="1005840"/>
-            <a:ext cx="804672" cy="164592"/>
+            <a:off x="365760" y="3008376"/>
+            <a:ext cx="219456" cy="219456"/>
           </a:xfrm>
           <a:prstGeom prst="rect">
             <a:avLst/>
@@ -3971,190 +4394,79 @@
       </p:sp>
       <p:sp>
         <p:nvSpPr>
-          <p:cNvPr id="25" name="Rectangle 24"/>
+          <p:cNvPr id="36" name="TextBox 35"/>
+          <p:cNvSpPr txBox="1"/>
+          <p:nvPr/>
+        </p:nvSpPr>
+        <p:spPr>
+          <a:xfrm>
+            <a:off x="365760" y="2990088"/>
+            <a:ext cx="219456" cy="237744"/>
+          </a:xfrm>
+          <a:prstGeom prst="rect">
+            <a:avLst/>
+          </a:prstGeom>
+          <a:noFill/>
+        </p:spPr>
+        <p:txBody>
+          <a:bodyPr wrap="square"/>
+          <a:lstStyle/>
+          <a:p>
+            <a:pPr algn="ctr"/>
+            <a:r>
+              <a:rPr sz="900" b="1" i="0">
+                <a:solidFill>
+                  <a:srgbClr val="FFFFFF"/>
+                </a:solidFill>
+                <a:latin typeface="Poppins"/>
+              </a:rPr>
+              <a:t>✕</a:t>
+            </a:r>
+          </a:p>
+        </p:txBody>
+      </p:sp>
+      <p:sp>
+        <p:nvSpPr>
+          <p:cNvPr id="37" name="TextBox 36"/>
+          <p:cNvSpPr txBox="1"/>
+          <p:nvPr/>
+        </p:nvSpPr>
+        <p:spPr>
+          <a:xfrm>
+            <a:off x="676656" y="2907792"/>
+            <a:ext cx="4352544" cy="420624"/>
+          </a:xfrm>
+          <a:prstGeom prst="rect">
+            <a:avLst/>
+          </a:prstGeom>
+          <a:noFill/>
+        </p:spPr>
+        <p:txBody>
+          <a:bodyPr wrap="square"/>
+          <a:lstStyle/>
+          <a:p>
+            <a:pPr algn="l"/>
+            <a:r>
+              <a:rPr sz="1000" b="0" i="0">
+                <a:solidFill>
+                  <a:srgbClr val="F0BABA"/>
+                </a:solidFill>
+                <a:latin typeface="Poppins"/>
+              </a:rPr>
+              <a:t>Close rate collapsed from ~30% in July to ~7% in August</a:t>
+            </a:r>
+          </a:p>
+        </p:txBody>
+      </p:sp>
+      <p:sp>
+        <p:nvSpPr>
+          <p:cNvPr id="38" name="Rectangle 37"/>
           <p:cNvSpPr/>
           <p:nvPr/>
         </p:nvSpPr>
         <p:spPr>
           <a:xfrm>
-            <a:off x="4261104" y="1170432"/>
-            <a:ext cx="804672" cy="676656"/>
-          </a:xfrm>
-          <a:prstGeom prst="rect">
-            <a:avLst/>
-          </a:prstGeom>
-          <a:solidFill>
-            <a:srgbClr val="265872"/>
-          </a:solidFill>
-          <a:ln>
-            <a:solidFill>
-              <a:srgbClr val="FFFFFF"/>
-            </a:solidFill>
-          </a:ln>
-        </p:spPr>
-        <p:style>
-          <a:lnRef idx="1">
-            <a:schemeClr val="accent1"/>
-          </a:lnRef>
-          <a:fillRef idx="3">
-            <a:schemeClr val="accent1"/>
-          </a:fillRef>
-          <a:effectRef idx="2">
-            <a:schemeClr val="accent1"/>
-          </a:effectRef>
-          <a:fontRef idx="minor">
-            <a:schemeClr val="lt1"/>
-          </a:fontRef>
-        </p:style>
-        <p:txBody>
-          <a:bodyPr rtlCol="0" anchor="ctr"/>
-          <a:lstStyle/>
-          <a:p>
-            <a:pPr algn="ctr"/>
-          </a:p>
-        </p:txBody>
-      </p:sp>
-      <p:sp>
-        <p:nvSpPr>
-          <p:cNvPr id="26" name="TextBox 25"/>
-          <p:cNvSpPr txBox="1"/>
-          <p:nvPr/>
-        </p:nvSpPr>
-        <p:spPr>
-          <a:xfrm>
-            <a:off x="4315968" y="1188720"/>
-            <a:ext cx="694944" cy="237744"/>
-          </a:xfrm>
-          <a:prstGeom prst="rect">
-            <a:avLst/>
-          </a:prstGeom>
-          <a:noFill/>
-        </p:spPr>
-        <p:txBody>
-          <a:bodyPr wrap="square"/>
-          <a:lstStyle/>
-          <a:p>
-            <a:pPr algn="l"/>
-            <a:r>
-              <a:rPr sz="800" b="1" i="0">
-                <a:solidFill>
-                  <a:srgbClr val="FFFFFF"/>
-                </a:solidFill>
-                <a:latin typeface="Poppins"/>
-              </a:rPr>
-              <a:t>Profit Plan</a:t>
-            </a:r>
-          </a:p>
-        </p:txBody>
-      </p:sp>
-      <p:sp>
-        <p:nvSpPr>
-          <p:cNvPr id="27" name="TextBox 26"/>
-          <p:cNvSpPr txBox="1"/>
-          <p:nvPr/>
-        </p:nvSpPr>
-        <p:spPr>
-          <a:xfrm>
-            <a:off x="4315968" y="1417320"/>
-            <a:ext cx="694944" cy="182880"/>
-          </a:xfrm>
-          <a:prstGeom prst="rect">
-            <a:avLst/>
-          </a:prstGeom>
-          <a:noFill/>
-        </p:spPr>
-        <p:txBody>
-          <a:bodyPr wrap="square"/>
-          <a:lstStyle/>
-          <a:p>
-            <a:pPr algn="l"/>
-            <a:r>
-              <a:rPr sz="700" b="1" i="0">
-                <a:solidFill>
-                  <a:srgbClr val="C0392B"/>
-                </a:solidFill>
-                <a:latin typeface="Poppins"/>
-              </a:rPr>
-              <a:t>RED</a:t>
-            </a:r>
-          </a:p>
-        </p:txBody>
-      </p:sp>
-      <p:sp>
-        <p:nvSpPr>
-          <p:cNvPr id="28" name="TextBox 27"/>
-          <p:cNvSpPr txBox="1"/>
-          <p:nvPr/>
-        </p:nvSpPr>
-        <p:spPr>
-          <a:xfrm>
-            <a:off x="4315968" y="1591056"/>
-            <a:ext cx="694944" cy="237744"/>
-          </a:xfrm>
-          <a:prstGeom prst="rect">
-            <a:avLst/>
-          </a:prstGeom>
-          <a:noFill/>
-        </p:spPr>
-        <p:txBody>
-          <a:bodyPr wrap="square"/>
-          <a:lstStyle/>
-          <a:p>
-            <a:pPr algn="l"/>
-            <a:r>
-              <a:rPr sz="700" b="0" i="0">
-                <a:solidFill>
-                  <a:srgbClr val="8BADD0"/>
-                </a:solidFill>
-                <a:latin typeface="Poppins"/>
-              </a:rPr>
-              <a:t>No profit visibility</a:t>
-            </a:r>
-          </a:p>
-        </p:txBody>
-      </p:sp>
-      <p:sp>
-        <p:nvSpPr>
-          <p:cNvPr id="29" name="TextBox 28"/>
-          <p:cNvSpPr txBox="1"/>
-          <p:nvPr/>
-        </p:nvSpPr>
-        <p:spPr>
-          <a:xfrm>
-            <a:off x="256032" y="1956816"/>
-            <a:ext cx="4846320" cy="219456"/>
-          </a:xfrm>
-          <a:prstGeom prst="rect">
-            <a:avLst/>
-          </a:prstGeom>
-          <a:noFill/>
-        </p:spPr>
-        <p:txBody>
-          <a:bodyPr wrap="square"/>
-          <a:lstStyle/>
-          <a:p>
-            <a:pPr algn="l"/>
-            <a:r>
-              <a:rPr sz="800" b="1" i="0">
-                <a:solidFill>
-                  <a:srgbClr val="69CD2B"/>
-                </a:solidFill>
-                <a:latin typeface="Poppins"/>
-              </a:rPr>
-              <a:t>KEY FINDINGS</a:t>
-            </a:r>
-          </a:p>
-        </p:txBody>
-      </p:sp>
-      <p:sp>
-        <p:nvSpPr>
-          <p:cNvPr id="30" name="Rectangle 29"/>
-          <p:cNvSpPr/>
-          <p:nvPr/>
-        </p:nvSpPr>
-        <p:spPr>
-          <a:xfrm>
-            <a:off x="256032" y="2212848"/>
+            <a:off x="256032" y="3456432"/>
             <a:ext cx="4846320" cy="566928"/>
           </a:xfrm>
           <a:prstGeom prst="rect">
@@ -4193,13 +4505,13 @@
       </p:sp>
       <p:sp>
         <p:nvSpPr>
-          <p:cNvPr id="31" name="Rectangle 30"/>
+          <p:cNvPr id="39" name="Rectangle 38"/>
           <p:cNvSpPr/>
           <p:nvPr/>
         </p:nvSpPr>
         <p:spPr>
           <a:xfrm>
-            <a:off x="365760" y="2386584"/>
+            <a:off x="365760" y="3630168"/>
             <a:ext cx="219456" cy="219456"/>
           </a:xfrm>
           <a:prstGeom prst="rect">
@@ -4238,318 +4550,6 @@
       </p:sp>
       <p:sp>
         <p:nvSpPr>
-          <p:cNvPr id="32" name="TextBox 31"/>
-          <p:cNvSpPr txBox="1"/>
-          <p:nvPr/>
-        </p:nvSpPr>
-        <p:spPr>
-          <a:xfrm>
-            <a:off x="365760" y="2368296"/>
-            <a:ext cx="219456" cy="237744"/>
-          </a:xfrm>
-          <a:prstGeom prst="rect">
-            <a:avLst/>
-          </a:prstGeom>
-          <a:noFill/>
-        </p:spPr>
-        <p:txBody>
-          <a:bodyPr wrap="square"/>
-          <a:lstStyle/>
-          <a:p>
-            <a:pPr algn="ctr"/>
-            <a:r>
-              <a:rPr sz="900" b="1" i="0">
-                <a:solidFill>
-                  <a:srgbClr val="FFFFFF"/>
-                </a:solidFill>
-                <a:latin typeface="Poppins"/>
-              </a:rPr>
-              <a:t>✕</a:t>
-            </a:r>
-          </a:p>
-        </p:txBody>
-      </p:sp>
-      <p:sp>
-        <p:nvSpPr>
-          <p:cNvPr id="33" name="TextBox 32"/>
-          <p:cNvSpPr txBox="1"/>
-          <p:nvPr/>
-        </p:nvSpPr>
-        <p:spPr>
-          <a:xfrm>
-            <a:off x="676656" y="2286000"/>
-            <a:ext cx="4352544" cy="420624"/>
-          </a:xfrm>
-          <a:prstGeom prst="rect">
-            <a:avLst/>
-          </a:prstGeom>
-          <a:noFill/>
-        </p:spPr>
-        <p:txBody>
-          <a:bodyPr wrap="square"/>
-          <a:lstStyle/>
-          <a:p>
-            <a:pPr algn="l"/>
-            <a:r>
-              <a:rPr sz="1000" b="0" i="0">
-                <a:solidFill>
-                  <a:srgbClr val="F0BABA"/>
-                </a:solidFill>
-                <a:latin typeface="Poppins"/>
-              </a:rPr>
-              <a:t>Unprofitable $5,800/mo PPC produces ~1 client a month</a:t>
-            </a:r>
-          </a:p>
-        </p:txBody>
-      </p:sp>
-      <p:sp>
-        <p:nvSpPr>
-          <p:cNvPr id="34" name="Rectangle 33"/>
-          <p:cNvSpPr/>
-          <p:nvPr/>
-        </p:nvSpPr>
-        <p:spPr>
-          <a:xfrm>
-            <a:off x="256032" y="2834640"/>
-            <a:ext cx="4846320" cy="566928"/>
-          </a:xfrm>
-          <a:prstGeom prst="rect">
-            <a:avLst/>
-          </a:prstGeom>
-          <a:solidFill>
-            <a:srgbClr val="2C1010"/>
-          </a:solidFill>
-          <a:ln>
-            <a:solidFill>
-              <a:srgbClr val="FFFFFF"/>
-            </a:solidFill>
-          </a:ln>
-        </p:spPr>
-        <p:style>
-          <a:lnRef idx="1">
-            <a:schemeClr val="accent1"/>
-          </a:lnRef>
-          <a:fillRef idx="3">
-            <a:schemeClr val="accent1"/>
-          </a:fillRef>
-          <a:effectRef idx="2">
-            <a:schemeClr val="accent1"/>
-          </a:effectRef>
-          <a:fontRef idx="minor">
-            <a:schemeClr val="lt1"/>
-          </a:fontRef>
-        </p:style>
-        <p:txBody>
-          <a:bodyPr rtlCol="0" anchor="ctr"/>
-          <a:lstStyle/>
-          <a:p>
-            <a:pPr algn="ctr"/>
-          </a:p>
-        </p:txBody>
-      </p:sp>
-      <p:sp>
-        <p:nvSpPr>
-          <p:cNvPr id="35" name="Rectangle 34"/>
-          <p:cNvSpPr/>
-          <p:nvPr/>
-        </p:nvSpPr>
-        <p:spPr>
-          <a:xfrm>
-            <a:off x="365760" y="3008376"/>
-            <a:ext cx="219456" cy="219456"/>
-          </a:xfrm>
-          <a:prstGeom prst="rect">
-            <a:avLst/>
-          </a:prstGeom>
-          <a:solidFill>
-            <a:srgbClr val="C0392B"/>
-          </a:solidFill>
-          <a:ln>
-            <a:solidFill>
-              <a:srgbClr val="FFFFFF"/>
-            </a:solidFill>
-          </a:ln>
-        </p:spPr>
-        <p:style>
-          <a:lnRef idx="1">
-            <a:schemeClr val="accent1"/>
-          </a:lnRef>
-          <a:fillRef idx="3">
-            <a:schemeClr val="accent1"/>
-          </a:fillRef>
-          <a:effectRef idx="2">
-            <a:schemeClr val="accent1"/>
-          </a:effectRef>
-          <a:fontRef idx="minor">
-            <a:schemeClr val="lt1"/>
-          </a:fontRef>
-        </p:style>
-        <p:txBody>
-          <a:bodyPr rtlCol="0" anchor="ctr"/>
-          <a:lstStyle/>
-          <a:p>
-            <a:pPr algn="ctr"/>
-          </a:p>
-        </p:txBody>
-      </p:sp>
-      <p:sp>
-        <p:nvSpPr>
-          <p:cNvPr id="36" name="TextBox 35"/>
-          <p:cNvSpPr txBox="1"/>
-          <p:nvPr/>
-        </p:nvSpPr>
-        <p:spPr>
-          <a:xfrm>
-            <a:off x="365760" y="2990088"/>
-            <a:ext cx="219456" cy="237744"/>
-          </a:xfrm>
-          <a:prstGeom prst="rect">
-            <a:avLst/>
-          </a:prstGeom>
-          <a:noFill/>
-        </p:spPr>
-        <p:txBody>
-          <a:bodyPr wrap="square"/>
-          <a:lstStyle/>
-          <a:p>
-            <a:pPr algn="ctr"/>
-            <a:r>
-              <a:rPr sz="900" b="1" i="0">
-                <a:solidFill>
-                  <a:srgbClr val="FFFFFF"/>
-                </a:solidFill>
-                <a:latin typeface="Poppins"/>
-              </a:rPr>
-              <a:t>✕</a:t>
-            </a:r>
-          </a:p>
-        </p:txBody>
-      </p:sp>
-      <p:sp>
-        <p:nvSpPr>
-          <p:cNvPr id="37" name="TextBox 36"/>
-          <p:cNvSpPr txBox="1"/>
-          <p:nvPr/>
-        </p:nvSpPr>
-        <p:spPr>
-          <a:xfrm>
-            <a:off x="676656" y="2907792"/>
-            <a:ext cx="4352544" cy="420624"/>
-          </a:xfrm>
-          <a:prstGeom prst="rect">
-            <a:avLst/>
-          </a:prstGeom>
-          <a:noFill/>
-        </p:spPr>
-        <p:txBody>
-          <a:bodyPr wrap="square"/>
-          <a:lstStyle/>
-          <a:p>
-            <a:pPr algn="l"/>
-            <a:r>
-              <a:rPr sz="1000" b="0" i="0">
-                <a:solidFill>
-                  <a:srgbClr val="F0BABA"/>
-                </a:solidFill>
-                <a:latin typeface="Poppins"/>
-              </a:rPr>
-              <a:t>Close rate collapsed from ~30% in July to ~7% in August</a:t>
-            </a:r>
-          </a:p>
-        </p:txBody>
-      </p:sp>
-      <p:sp>
-        <p:nvSpPr>
-          <p:cNvPr id="38" name="Rectangle 37"/>
-          <p:cNvSpPr/>
-          <p:nvPr/>
-        </p:nvSpPr>
-        <p:spPr>
-          <a:xfrm>
-            <a:off x="256032" y="3456432"/>
-            <a:ext cx="4846320" cy="566928"/>
-          </a:xfrm>
-          <a:prstGeom prst="rect">
-            <a:avLst/>
-          </a:prstGeom>
-          <a:solidFill>
-            <a:srgbClr val="2C1010"/>
-          </a:solidFill>
-          <a:ln>
-            <a:solidFill>
-              <a:srgbClr val="FFFFFF"/>
-            </a:solidFill>
-          </a:ln>
-        </p:spPr>
-        <p:style>
-          <a:lnRef idx="1">
-            <a:schemeClr val="accent1"/>
-          </a:lnRef>
-          <a:fillRef idx="3">
-            <a:schemeClr val="accent1"/>
-          </a:fillRef>
-          <a:effectRef idx="2">
-            <a:schemeClr val="accent1"/>
-          </a:effectRef>
-          <a:fontRef idx="minor">
-            <a:schemeClr val="lt1"/>
-          </a:fontRef>
-        </p:style>
-        <p:txBody>
-          <a:bodyPr rtlCol="0" anchor="ctr"/>
-          <a:lstStyle/>
-          <a:p>
-            <a:pPr algn="ctr"/>
-          </a:p>
-        </p:txBody>
-      </p:sp>
-      <p:sp>
-        <p:nvSpPr>
-          <p:cNvPr id="39" name="Rectangle 38"/>
-          <p:cNvSpPr/>
-          <p:nvPr/>
-        </p:nvSpPr>
-        <p:spPr>
-          <a:xfrm>
-            <a:off x="365760" y="3630168"/>
-            <a:ext cx="219456" cy="219456"/>
-          </a:xfrm>
-          <a:prstGeom prst="rect">
-            <a:avLst/>
-          </a:prstGeom>
-          <a:solidFill>
-            <a:srgbClr val="C0392B"/>
-          </a:solidFill>
-          <a:ln>
-            <a:solidFill>
-              <a:srgbClr val="FFFFFF"/>
-            </a:solidFill>
-          </a:ln>
-        </p:spPr>
-        <p:style>
-          <a:lnRef idx="1">
-            <a:schemeClr val="accent1"/>
-          </a:lnRef>
-          <a:fillRef idx="3">
-            <a:schemeClr val="accent1"/>
-          </a:fillRef>
-          <a:effectRef idx="2">
-            <a:schemeClr val="accent1"/>
-          </a:effectRef>
-          <a:fontRef idx="minor">
-            <a:schemeClr val="lt1"/>
-          </a:fontRef>
-        </p:style>
-        <p:txBody>
-          <a:bodyPr rtlCol="0" anchor="ctr"/>
-          <a:lstStyle/>
-          <a:p>
-            <a:pPr algn="ctr"/>
-          </a:p>
-        </p:txBody>
-      </p:sp>
-      <p:sp>
-        <p:nvSpPr>
           <p:cNvPr id="40" name="TextBox 39"/>
           <p:cNvSpPr txBox="1"/>
           <p:nvPr/>
@@ -5077,7 +5077,7 @@
                 </a:solidFill>
                 <a:latin typeface="Poppins"/>
               </a:rPr>
-              <a:t>Confianza Legal</a:t>
+              <a:t>Poseidon Defense APC</a:t>
             </a:r>
           </a:p>
         </p:txBody>
@@ -5143,7 +5143,7 @@
                 </a:solidFill>
                 <a:latin typeface="Poppins"/>
               </a:rPr>
-              <a:t>Built a La Verne page</a:t>
+              <a:t>Built La Verne sub-area pages</a:t>
             </a:r>
           </a:p>
         </p:txBody>
@@ -5221,7 +5221,7 @@
                 </a:solidFill>
                 <a:latin typeface="Poppins"/>
               </a:rPr>
-              <a:t>Law Offices of Ali Komaili</a:t>
+              <a:t>Confianza Legal</a:t>
             </a:r>
           </a:p>
         </p:txBody>
@@ -5254,7 +5254,7 @@
                 </a:solidFill>
                 <a:latin typeface="Poppins"/>
               </a:rPr>
-              <a:t>Strong sentiment</a:t>
+              <a:t>Larger review base</a:t>
             </a:r>
           </a:p>
         </p:txBody>
@@ -5287,7 +5287,7 @@
                 </a:solidFill>
                 <a:latin typeface="Poppins"/>
               </a:rPr>
-              <a:t>30 min away, still visible</a:t>
+              <a:t>4 dedicated city landing pages</a:t>
             </a:r>
           </a:p>
         </p:txBody>
@@ -5365,7 +5365,7 @@
                 </a:solidFill>
                 <a:latin typeface="Poppins"/>
               </a:rPr>
-              <a:t>Poseidon Defense APC</a:t>
+              <a:t>Law Offices of Ali Komaili</a:t>
             </a:r>
           </a:p>
         </p:txBody>
@@ -5398,7 +5398,7 @@
                 </a:solidFill>
                 <a:latin typeface="Poppins"/>
               </a:rPr>
-              <a:t>Appears in DUI search</a:t>
+              <a:t>Spotless 5-star</a:t>
             </a:r>
           </a:p>
         </p:txBody>
@@ -5431,7 +5431,7 @@
                 </a:solidFill>
                 <a:latin typeface="Poppins"/>
               </a:rPr>
-              <a:t>Lucero, PC does not</a:t>
+              <a:t>30 min away, still visible</a:t>
             </a:r>
           </a:p>
         </p:txBody>

</xml_diff>